<commit_message>
Remove author name from ПР3 slide
</commit_message>
<xml_diff>
--- a/ОЭЗИ/ПР3_ТЭО_ИС_АудитИБ/ОЭЗИ_ПР3_ТЭО_презентация.pptx
+++ b/ОЭЗИ/ПР3_ТЭО_ИС_АудитИБ/ОЭЗИ_ПР3_ТЭО_презентация.pptx
@@ -3084,6 +3084,145 @@
 </p:sldMaster>
 </file>
 
+<file path=ppt/slides/slide1.xml><?xml version="1.0" encoding="utf-8"?>
+<p:sld xmlns:a="http://schemas.openxmlformats.org/drawingml/2006/main" xmlns:p="http://schemas.openxmlformats.org/presentationml/2006/main" xmlns:r="http://schemas.openxmlformats.org/officeDocument/2006/relationships">
+  <p:cSld>
+    <p:spTree>
+      <p:nvGrpSpPr>
+        <p:cNvPr id="1" name=""/>
+        <p:cNvGrpSpPr/>
+        <p:nvPr/>
+      </p:nvGrpSpPr>
+      <p:grpSpPr/>
+      <p:sp>
+        <p:nvSpPr>
+          <p:cNvPr id="2" name="TextBox 1"/>
+          <p:cNvSpPr txBox="1"/>
+          <p:nvPr/>
+        </p:nvSpPr>
+        <p:spPr>
+          <a:xfrm>
+            <a:off x="548640" y="320040"/>
+            <a:ext cx="10972800" cy="731520"/>
+          </a:xfrm>
+          <a:prstGeom prst="rect">
+            <a:avLst/>
+          </a:prstGeom>
+          <a:noFill/>
+        </p:spPr>
+        <p:txBody>
+          <a:bodyPr wrap="none">
+            <a:spAutoFit/>
+          </a:bodyPr>
+          <a:lstStyle/>
+          <a:p>
+            <a:pPr>
+              <a:defRPr sz="2600" b="1">
+                <a:latin typeface="Times New Roman"/>
+              </a:defRPr>
+            </a:pPr>
+            <a:r>
+              <a:t>1. Введение (ГОСТ 24.202)</a:t>
+            </a:r>
+          </a:p>
+        </p:txBody>
+      </p:sp>
+      <p:sp>
+        <p:nvSpPr>
+          <p:cNvPr id="3" name="TextBox 2"/>
+          <p:cNvSpPr txBox="1"/>
+          <p:nvPr/>
+        </p:nvSpPr>
+        <p:spPr>
+          <a:xfrm>
+            <a:off x="731520" y="1188720"/>
+            <a:ext cx="10515600" cy="5303520"/>
+          </a:xfrm>
+          <a:prstGeom prst="rect">
+            <a:avLst/>
+          </a:prstGeom>
+          <a:noFill/>
+        </p:spPr>
+        <p:txBody>
+          <a:bodyPr wrap="square">
+            <a:spAutoFit/>
+          </a:bodyPr>
+          <a:lstStyle/>
+          <a:p>
+            <a:pPr>
+              <a:spcAft>
+                <a:spcPts val="800"/>
+              </a:spcAft>
+              <a:defRPr sz="1800">
+                <a:latin typeface="Times New Roman"/>
+              </a:defRPr>
+            </a:pPr>
+            <a:r>
+              <a:t>Заказчик: ООО «СеверМодуль» (СПб), шкафы управления / СКУД</a:t>
+            </a:r>
+          </a:p>
+          <a:p>
+            <a:pPr>
+              <a:spcAft>
+                <a:spcPts val="800"/>
+              </a:spcAft>
+              <a:defRPr sz="1800">
+                <a:latin typeface="Times New Roman"/>
+              </a:defRPr>
+            </a:pPr>
+            <a:r>
+              <a:t>Проект: ИС учёта аудитов ИБ «АудитИБ»</a:t>
+            </a:r>
+          </a:p>
+          <a:p>
+            <a:pPr>
+              <a:spcAft>
+                <a:spcPts val="800"/>
+              </a:spcAft>
+              <a:defRPr sz="1800">
+                <a:latin typeface="Times New Roman"/>
+              </a:defRPr>
+            </a:pPr>
+            <a:r>
+              <a:t>Инвестиции I₀ = 480 000 руб. (собственные средства)</a:t>
+            </a:r>
+          </a:p>
+          <a:p>
+            <a:pPr>
+              <a:spcAft>
+                <a:spcPts val="800"/>
+              </a:spcAft>
+              <a:defRPr sz="1800">
+                <a:latin typeface="Times New Roman"/>
+              </a:defRPr>
+            </a:pPr>
+            <a:r>
+              <a:t>Срок MVP: 5 месяцев (март–июль 2026)</a:t>
+            </a:r>
+          </a:p>
+          <a:p>
+            <a:pPr>
+              <a:spcAft>
+                <a:spcPts val="800"/>
+              </a:spcAft>
+              <a:defRPr sz="1800">
+                <a:latin typeface="Times New Roman"/>
+              </a:defRPr>
+            </a:pPr>
+            <a:r>
+              <a:t>База: ГОСТ 24.202-80, пособие Павловой Е.А., материалы ПР1</a:t>
+            </a:r>
+          </a:p>
+        </p:txBody>
+      </p:sp>
+    </p:spTree>
+  </p:cSld>
+  <p:clrMapOvr>
+    <a:masterClrMapping/>
+  </p:clrMapOvr>
+</p:sld>
+</file>
+
 <file path=ppt/slides/slide2.xml><?xml version="1.0" encoding="utf-8"?>
 <p:sld xmlns:a="http://schemas.openxmlformats.org/drawingml/2006/main" xmlns:p="http://schemas.openxmlformats.org/presentationml/2006/main" xmlns:r="http://schemas.openxmlformats.org/officeDocument/2006/relationships">
   <p:cSld>
@@ -3122,7 +3261,7 @@
               </a:defRPr>
             </a:pPr>
             <a:r>
-              <a:t>1. Введение (ГОСТ 24.202)</a:t>
+              <a:t>2. Объект и недостатки текущего управления</a:t>
             </a:r>
           </a:p>
         </p:txBody>
@@ -3158,7 +3297,7 @@
               </a:defRPr>
             </a:pPr>
             <a:r>
-              <a:t>Заказчик: ООО «СеверМодуль» (СПб), шкафы управления / СКУД</a:t>
+              <a:t>Сейчас: Excel, бумага, ручная сборка отчётов 4–8 ч</a:t>
             </a:r>
           </a:p>
           <a:p>
@@ -3171,7 +3310,7 @@
               </a:defRPr>
             </a:pPr>
             <a:r>
-              <a:t>Проект: ИС учёта аудитов ИБ «АудитИБ»</a:t>
+              <a:t>Нет единого статуса устранения замечаний и KPI</a:t>
             </a:r>
           </a:p>
           <a:p>
@@ -3184,7 +3323,7 @@
               </a:defRPr>
             </a:pPr>
             <a:r>
-              <a:t>Инвестиции I₀ = 480 000 руб. (собственные средства)</a:t>
+              <a:t>Потери: труд инженера + риск простоя 80–120 тыс. руб.</a:t>
             </a:r>
           </a:p>
           <a:p>
@@ -3197,7 +3336,7 @@
               </a:defRPr>
             </a:pPr>
             <a:r>
-              <a:t>Срок MVP: 5 месяцев (март–июль 2026)</a:t>
+              <a:t>Недополученная выручка пакетов сопровождения SMB</a:t>
             </a:r>
           </a:p>
           <a:p>
@@ -3210,7 +3349,7 @@
               </a:defRPr>
             </a:pPr>
             <a:r>
-              <a:t>База: ГОСТ 24.202-80, пособие Павловой Е.А., материалы ПР1</a:t>
+              <a:t>Готовность: процессы описаны курсом, есть ответственный за ИБ</a:t>
             </a:r>
           </a:p>
         </p:txBody>
@@ -3261,7 +3400,7 @@
               </a:defRPr>
             </a:pPr>
             <a:r>
-              <a:t>2. Объект и недостатки текущего управления</a:t>
+              <a:t>3. Цели, критерии и ограничения</a:t>
             </a:r>
           </a:p>
         </p:txBody>
@@ -3297,7 +3436,7 @@
               </a:defRPr>
             </a:pPr>
             <a:r>
-              <a:t>Сейчас: Excel, бумага, ручная сборка отчётов 4–8 ч</a:t>
+              <a:t>Время отчёта: 6 ч → ≤ 1,5 ч</a:t>
             </a:r>
           </a:p>
           <a:p>
@@ -3310,7 +3449,7 @@
               </a:defRPr>
             </a:pPr>
             <a:r>
-              <a:t>Нет единого статуса устранения замечаний и KPI</a:t>
+              <a:t>Закрытие замечаний в срок: 50% → ≥ 85%</a:t>
             </a:r>
           </a:p>
           <a:p>
@@ -3323,7 +3462,7 @@
               </a:defRPr>
             </a:pPr>
             <a:r>
-              <a:t>Потери: труд инженера + риск простоя 80–120 тыс. руб.</a:t>
+              <a:t>NPV &gt; 0, PI &gt; 1, IRR &gt; 15%, PP ≤ 3 лет</a:t>
             </a:r>
           </a:p>
           <a:p>
@@ -3336,20 +3475,7 @@
               </a:defRPr>
             </a:pPr>
             <a:r>
-              <a:t>Недополученная выручка пакетов сопровождения SMB</a:t>
-            </a:r>
-          </a:p>
-          <a:p>
-            <a:pPr>
-              <a:spcAft>
-                <a:spcPts val="800"/>
-              </a:spcAft>
-              <a:defRPr sz="1800">
-                <a:latin typeface="Times New Roman"/>
-              </a:defRPr>
-            </a:pPr>
-            <a:r>
-              <a:t>Готовность: процессы описаны курсом, есть ответственный за ИБ</a:t>
+              <a:t>Бюджет ≤ 480 000 руб., данные в РФ, MVP ≤ 5 мес.</a:t>
             </a:r>
           </a:p>
         </p:txBody>
@@ -3400,7 +3526,7 @@
               </a:defRPr>
             </a:pPr>
             <a:r>
-              <a:t>3. Цели, критерии и ограничения</a:t>
+              <a:t>4. Функции ИС и очереди внедрения</a:t>
             </a:r>
           </a:p>
         </p:txBody>
@@ -3436,7 +3562,7 @@
               </a:defRPr>
             </a:pPr>
             <a:r>
-              <a:t>Время отчёта: 6 ч → ≤ 1,5 ч</a:t>
+              <a:t>Очередь 1 (MVP): реестр, чек-листы, журнал, календарь, PDF, роли</a:t>
             </a:r>
           </a:p>
           <a:p>
@@ -3449,7 +3575,7 @@
               </a:defRPr>
             </a:pPr>
             <a:r>
-              <a:t>Закрытие замечаний в срок: 50% → ≥ 85%</a:t>
+              <a:t>Очередь 2: кабинет заказчика, KPI, связка с модулями курса, API</a:t>
             </a:r>
           </a:p>
           <a:p>
@@ -3462,7 +3588,7 @@
               </a:defRPr>
             </a:pPr>
             <a:r>
-              <a:t>NPV &gt; 0, PI &gt; 1, IRR &gt; 15%, PP ≤ 3 лет</a:t>
+              <a:t>Требования: роли, резерв БД, отчёт ≤ 1 мин, отклик ≤ 2 с</a:t>
             </a:r>
           </a:p>
           <a:p>
@@ -3475,7 +3601,7 @@
               </a:defRPr>
             </a:pPr>
             <a:r>
-              <a:t>Бюджет ≤ 480 000 руб., данные в РФ, MVP ≤ 5 мес.</a:t>
+              <a:t>Специфика: мобильная форма обхода цеха (ПЛК, шкаф, СКУД)</a:t>
             </a:r>
           </a:p>
         </p:txBody>
@@ -3526,7 +3652,7 @@
               </a:defRPr>
             </a:pPr>
             <a:r>
-              <a:t>4. Функции ИС и очереди внедрения</a:t>
+              <a:t>5. Затраты и ожидаемый эффект</a:t>
             </a:r>
           </a:p>
         </p:txBody>
@@ -3562,7 +3688,7 @@
               </a:defRPr>
             </a:pPr>
             <a:r>
-              <a:t>Очередь 1 (MVP): реестр, чек-листы, журнал, календарь, PDF, роли</a:t>
+              <a:t>I₀ = 480 000 руб. (разработка, инфра, обучение)</a:t>
             </a:r>
           </a:p>
           <a:p>
@@ -3575,7 +3701,7 @@
               </a:defRPr>
             </a:pPr>
             <a:r>
-              <a:t>Очередь 2: кабинет заказчика, KPI, связка с модулями курса, API</a:t>
+              <a:t>NCF по годам: 180 000, 220 000, 260 000, 300 000 руб.</a:t>
             </a:r>
           </a:p>
           <a:p>
@@ -3588,7 +3714,7 @@
               </a:defRPr>
             </a:pPr>
             <a:r>
-              <a:t>Требования: роли, резерв БД, отчёт ≤ 1 мин, отклик ≤ 2 с</a:t>
+              <a:t>Qk = 4.0 клиента; спрос 8 &gt; Qk</a:t>
             </a:r>
           </a:p>
           <a:p>
@@ -3601,7 +3727,20 @@
               </a:defRPr>
             </a:pPr>
             <a:r>
-              <a:t>Специфика: мобильная форма обхода цеха (ПЛК, шкаф, СКУД)</a:t>
+              <a:t>NPV ≈ 185 354 руб.; PI = 1.39; IRR ≈ 31.4%</a:t>
+            </a:r>
+          </a:p>
+          <a:p>
+            <a:pPr>
+              <a:spcAft>
+                <a:spcPts val="800"/>
+              </a:spcAft>
+              <a:defRPr sz="1800">
+                <a:latin typeface="Times New Roman"/>
+              </a:defRPr>
+            </a:pPr>
+            <a:r>
+              <a:t>PP ≈ 2.3 г.; DPP ≈ 2.9 г.</a:t>
             </a:r>
           </a:p>
         </p:txBody>
@@ -3652,7 +3791,7 @@
               </a:defRPr>
             </a:pPr>
             <a:r>
-              <a:t>5. Затраты и ожидаемый эффект</a:t>
+              <a:t>6. Вывод и рекомендации</a:t>
             </a:r>
           </a:p>
         </p:txBody>
@@ -3688,7 +3827,7 @@
               </a:defRPr>
             </a:pPr>
             <a:r>
-              <a:t>I₀ = 480 000 руб. (разработка, инфра, обучение)</a:t>
+              <a:t>Решение: создание ИС целесообразно (положительное)</a:t>
             </a:r>
           </a:p>
           <a:p>
@@ -3701,7 +3840,7 @@
               </a:defRPr>
             </a:pPr>
             <a:r>
-              <a:t>NCF по годам: 180 000, 220 000, 260 000, 300 000 руб.</a:t>
+              <a:t>Внедрить регламент фиксации аудитов только в ИС</a:t>
             </a:r>
           </a:p>
           <a:p>
@@ -3714,7 +3853,7 @@
               </a:defRPr>
             </a:pPr>
             <a:r>
-              <a:t>Qk = 4.0 клиента; спрос 8 &gt; Qk</a:t>
+              <a:t>Финансирование — собственные средства; очередь 2 из CF</a:t>
             </a:r>
           </a:p>
           <a:p>
@@ -3727,7 +3866,7 @@
               </a:defRPr>
             </a:pPr>
             <a:r>
-              <a:t>NPV ≈ 185 354 руб.; PI = 1.39; IRR ≈ 31.4%</a:t>
+              <a:t>Детальный расчёт эффективности — в практической работе №4</a:t>
             </a:r>
           </a:p>
           <a:p>
@@ -3740,7 +3879,7 @@
               </a:defRPr>
             </a:pPr>
             <a:r>
-              <a:t>PP ≈ 2.3 г.; DPP ≈ 2.9 г.</a:t>
+              <a:t>Рекомендация: принять проект к реализации (MVP → развитие)</a:t>
             </a:r>
           </a:p>
         </p:txBody>
@@ -3771,145 +3910,6 @@
         </p:nvSpPr>
         <p:spPr>
           <a:xfrm>
-            <a:off x="548640" y="320040"/>
-            <a:ext cx="10972800" cy="731520"/>
-          </a:xfrm>
-          <a:prstGeom prst="rect">
-            <a:avLst/>
-          </a:prstGeom>
-          <a:noFill/>
-        </p:spPr>
-        <p:txBody>
-          <a:bodyPr wrap="none">
-            <a:spAutoFit/>
-          </a:bodyPr>
-          <a:lstStyle/>
-          <a:p>
-            <a:pPr>
-              <a:defRPr sz="2600" b="1">
-                <a:latin typeface="Times New Roman"/>
-              </a:defRPr>
-            </a:pPr>
-            <a:r>
-              <a:t>6. Вывод и рекомендации</a:t>
-            </a:r>
-          </a:p>
-        </p:txBody>
-      </p:sp>
-      <p:sp>
-        <p:nvSpPr>
-          <p:cNvPr id="3" name="TextBox 2"/>
-          <p:cNvSpPr txBox="1"/>
-          <p:nvPr/>
-        </p:nvSpPr>
-        <p:spPr>
-          <a:xfrm>
-            <a:off x="731520" y="1188720"/>
-            <a:ext cx="10515600" cy="5303520"/>
-          </a:xfrm>
-          <a:prstGeom prst="rect">
-            <a:avLst/>
-          </a:prstGeom>
-          <a:noFill/>
-        </p:spPr>
-        <p:txBody>
-          <a:bodyPr wrap="square">
-            <a:spAutoFit/>
-          </a:bodyPr>
-          <a:lstStyle/>
-          <a:p>
-            <a:pPr>
-              <a:spcAft>
-                <a:spcPts val="800"/>
-              </a:spcAft>
-              <a:defRPr sz="1800">
-                <a:latin typeface="Times New Roman"/>
-              </a:defRPr>
-            </a:pPr>
-            <a:r>
-              <a:t>Решение: создание ИС целесообразно (положительное)</a:t>
-            </a:r>
-          </a:p>
-          <a:p>
-            <a:pPr>
-              <a:spcAft>
-                <a:spcPts val="800"/>
-              </a:spcAft>
-              <a:defRPr sz="1800">
-                <a:latin typeface="Times New Roman"/>
-              </a:defRPr>
-            </a:pPr>
-            <a:r>
-              <a:t>Внедрить регламент фиксации аудитов только в ИС</a:t>
-            </a:r>
-          </a:p>
-          <a:p>
-            <a:pPr>
-              <a:spcAft>
-                <a:spcPts val="800"/>
-              </a:spcAft>
-              <a:defRPr sz="1800">
-                <a:latin typeface="Times New Roman"/>
-              </a:defRPr>
-            </a:pPr>
-            <a:r>
-              <a:t>Финансирование — собственные средства; очередь 2 из CF</a:t>
-            </a:r>
-          </a:p>
-          <a:p>
-            <a:pPr>
-              <a:spcAft>
-                <a:spcPts val="800"/>
-              </a:spcAft>
-              <a:defRPr sz="1800">
-                <a:latin typeface="Times New Roman"/>
-              </a:defRPr>
-            </a:pPr>
-            <a:r>
-              <a:t>Детальный расчёт эффективности — в практической работе №4</a:t>
-            </a:r>
-          </a:p>
-          <a:p>
-            <a:pPr>
-              <a:spcAft>
-                <a:spcPts val="800"/>
-              </a:spcAft>
-              <a:defRPr sz="1800">
-                <a:latin typeface="Times New Roman"/>
-              </a:defRPr>
-            </a:pPr>
-            <a:r>
-              <a:t>Рекомендация: принять проект к реализации (MVP → развитие)</a:t>
-            </a:r>
-          </a:p>
-        </p:txBody>
-      </p:sp>
-    </p:spTree>
-  </p:cSld>
-  <p:clrMapOvr>
-    <a:masterClrMapping/>
-  </p:clrMapOvr>
-</p:sld>
-</file>
-
-<file path=ppt/slides/slide8.xml><?xml version="1.0" encoding="utf-8"?>
-<p:sld xmlns:a="http://schemas.openxmlformats.org/drawingml/2006/main" xmlns:p="http://schemas.openxmlformats.org/presentationml/2006/main" xmlns:r="http://schemas.openxmlformats.org/officeDocument/2006/relationships">
-  <p:cSld>
-    <p:spTree>
-      <p:nvGrpSpPr>
-        <p:cNvPr id="1" name=""/>
-        <p:cNvGrpSpPr/>
-        <p:nvPr/>
-      </p:nvGrpSpPr>
-      <p:grpSpPr/>
-      <p:sp>
-        <p:nvSpPr>
-          <p:cNvPr id="2" name="TextBox 1"/>
-          <p:cNvSpPr txBox="1"/>
-          <p:nvPr/>
-        </p:nvSpPr>
-        <p:spPr>
-          <a:xfrm>
             <a:off x="731520" y="1828800"/>
             <a:ext cx="10515600" cy="1097280"/>
           </a:xfrm>
@@ -3964,10 +3964,6 @@
             </a:pPr>
             <a:r>
               <a:t>Вопросы?</a:t>
-            </a:r>
-            <a:br/>
-            <a:r>
-              <a:t>Калинкин П.В. · N3249 · ОЭЗИ · ИТМО</a:t>
             </a:r>
           </a:p>
         </p:txBody>

</xml_diff>